<commit_message>
added qr code feedback
</commit_message>
<xml_diff>
--- a/slides/brc_hazel_week_d4.pptx
+++ b/slides/brc_hazel_week_d4.pptx
@@ -5,7 +5,7 @@
     <p:sldMasterId id="2147483648" r:id="rId1"/>
   </p:sldMasterIdLst>
   <p:notesMasterIdLst>
-    <p:notesMasterId r:id="rId20"/>
+    <p:notesMasterId r:id="rId21"/>
   </p:notesMasterIdLst>
   <p:sldIdLst>
     <p:sldId id="257" r:id="rId2"/>
@@ -26,6 +26,7 @@
     <p:sldId id="285" r:id="rId17"/>
     <p:sldId id="307" r:id="rId18"/>
     <p:sldId id="315" r:id="rId19"/>
+    <p:sldId id="316" r:id="rId20"/>
   </p:sldIdLst>
   <p:sldSz cx="12192000" cy="6858000"/>
   <p:notesSz cx="6858000" cy="9144000"/>
@@ -214,7 +215,7 @@
           <a:p>
             <a:fld id="{C03B9CC4-35C2-F643-8821-8A26B4C2EFBC}" type="datetimeFigureOut">
               <a:rPr lang="en-US" smtClean="0"/>
-              <a:t>4/21/26</a:t>
+              <a:t>5/11/26</a:t>
             </a:fld>
             <a:endParaRPr lang="en-US"/>
           </a:p>
@@ -2019,7 +2020,7 @@
           <a:p>
             <a:fld id="{07922428-1601-1349-B82F-394AB362B944}" type="datetimeFigureOut">
               <a:rPr lang="en-US" smtClean="0"/>
-              <a:t>4/21/26</a:t>
+              <a:t>5/11/26</a:t>
             </a:fld>
             <a:endParaRPr lang="en-US"/>
           </a:p>
@@ -2217,7 +2218,7 @@
           <a:p>
             <a:fld id="{07922428-1601-1349-B82F-394AB362B944}" type="datetimeFigureOut">
               <a:rPr lang="en-US" smtClean="0"/>
-              <a:t>4/21/26</a:t>
+              <a:t>5/11/26</a:t>
             </a:fld>
             <a:endParaRPr lang="en-US"/>
           </a:p>
@@ -2425,7 +2426,7 @@
           <a:p>
             <a:fld id="{07922428-1601-1349-B82F-394AB362B944}" type="datetimeFigureOut">
               <a:rPr lang="en-US" smtClean="0"/>
-              <a:t>4/21/26</a:t>
+              <a:t>5/11/26</a:t>
             </a:fld>
             <a:endParaRPr lang="en-US"/>
           </a:p>
@@ -2623,7 +2624,7 @@
           <a:p>
             <a:fld id="{07922428-1601-1349-B82F-394AB362B944}" type="datetimeFigureOut">
               <a:rPr lang="en-US" smtClean="0"/>
-              <a:t>4/21/26</a:t>
+              <a:t>5/11/26</a:t>
             </a:fld>
             <a:endParaRPr lang="en-US"/>
           </a:p>
@@ -2898,7 +2899,7 @@
           <a:p>
             <a:fld id="{07922428-1601-1349-B82F-394AB362B944}" type="datetimeFigureOut">
               <a:rPr lang="en-US" smtClean="0"/>
-              <a:t>4/21/26</a:t>
+              <a:t>5/11/26</a:t>
             </a:fld>
             <a:endParaRPr lang="en-US"/>
           </a:p>
@@ -3163,7 +3164,7 @@
           <a:p>
             <a:fld id="{07922428-1601-1349-B82F-394AB362B944}" type="datetimeFigureOut">
               <a:rPr lang="en-US" smtClean="0"/>
-              <a:t>4/21/26</a:t>
+              <a:t>5/11/26</a:t>
             </a:fld>
             <a:endParaRPr lang="en-US"/>
           </a:p>
@@ -3575,7 +3576,7 @@
           <a:p>
             <a:fld id="{07922428-1601-1349-B82F-394AB362B944}" type="datetimeFigureOut">
               <a:rPr lang="en-US" smtClean="0"/>
-              <a:t>4/21/26</a:t>
+              <a:t>5/11/26</a:t>
             </a:fld>
             <a:endParaRPr lang="en-US"/>
           </a:p>
@@ -3716,7 +3717,7 @@
           <a:p>
             <a:fld id="{07922428-1601-1349-B82F-394AB362B944}" type="datetimeFigureOut">
               <a:rPr lang="en-US" smtClean="0"/>
-              <a:t>4/21/26</a:t>
+              <a:t>5/11/26</a:t>
             </a:fld>
             <a:endParaRPr lang="en-US"/>
           </a:p>
@@ -3829,7 +3830,7 @@
           <a:p>
             <a:fld id="{07922428-1601-1349-B82F-394AB362B944}" type="datetimeFigureOut">
               <a:rPr lang="en-US" smtClean="0"/>
-              <a:t>4/21/26</a:t>
+              <a:t>5/11/26</a:t>
             </a:fld>
             <a:endParaRPr lang="en-US"/>
           </a:p>
@@ -4140,7 +4141,7 @@
           <a:p>
             <a:fld id="{07922428-1601-1349-B82F-394AB362B944}" type="datetimeFigureOut">
               <a:rPr lang="en-US" smtClean="0"/>
-              <a:t>4/21/26</a:t>
+              <a:t>5/11/26</a:t>
             </a:fld>
             <a:endParaRPr lang="en-US"/>
           </a:p>
@@ -4428,7 +4429,7 @@
           <a:p>
             <a:fld id="{07922428-1601-1349-B82F-394AB362B944}" type="datetimeFigureOut">
               <a:rPr lang="en-US" smtClean="0"/>
-              <a:t>4/21/26</a:t>
+              <a:t>5/11/26</a:t>
             </a:fld>
             <a:endParaRPr lang="en-US"/>
           </a:p>
@@ -4669,7 +4670,7 @@
           <a:p>
             <a:fld id="{07922428-1601-1349-B82F-394AB362B944}" type="datetimeFigureOut">
               <a:rPr lang="en-US" smtClean="0"/>
-              <a:t>4/21/26</a:t>
+              <a:t>5/11/26</a:t>
             </a:fld>
             <a:endParaRPr lang="en-US"/>
           </a:p>
@@ -8913,7 +8914,7 @@
 </p:sld>
 </file>
 
-<file path=ppt/slides/slide2.xml><?xml version="1.0" encoding="utf-8"?>
+<file path=ppt/slides/slide19.xml><?xml version="1.0" encoding="utf-8"?>
 <p:sld xmlns:a="http://schemas.openxmlformats.org/drawingml/2006/main" xmlns:r="http://schemas.openxmlformats.org/officeDocument/2006/relationships" xmlns:p="http://schemas.openxmlformats.org/presentationml/2006/main">
   <p:cSld>
     <p:spTree>
@@ -9030,7 +9031,7 @@
         <p:spPr>
           <a:xfrm>
             <a:off x="1794669" y="2206232"/>
-            <a:ext cx="6591506" cy="1754326"/>
+            <a:ext cx="4606131" cy="2031325"/>
           </a:xfrm>
           <a:prstGeom prst="rect">
             <a:avLst/>
@@ -9135,6 +9136,303 @@
               </a14:hiddenFill>
             </a:ext>
           </a:extLst>
+        </p:spPr>
+      </p:pic>
+      <p:pic>
+        <p:nvPicPr>
+          <p:cNvPr id="4" name="Picture 3">
+            <a:extLst>
+              <a:ext uri="{FF2B5EF4-FFF2-40B4-BE49-F238E27FC236}">
+                <a16:creationId xmlns:a16="http://schemas.microsoft.com/office/drawing/2014/main" id="{7EAC7020-766F-B0AF-849C-A72B60F880DB}"/>
+              </a:ext>
+            </a:extLst>
+          </p:cNvPr>
+          <p:cNvPicPr>
+            <a:picLocks noChangeAspect="1"/>
+          </p:cNvPicPr>
+          <p:nvPr/>
+        </p:nvPicPr>
+        <p:blipFill>
+          <a:blip r:embed="rId4"/>
+          <a:stretch>
+            <a:fillRect/>
+          </a:stretch>
+        </p:blipFill>
+        <p:spPr>
+          <a:xfrm>
+            <a:off x="7012709" y="1714968"/>
+            <a:ext cx="4606131" cy="4577873"/>
+          </a:xfrm>
+          <a:prstGeom prst="rect">
+            <a:avLst/>
+          </a:prstGeom>
+        </p:spPr>
+      </p:pic>
+    </p:spTree>
+    <p:extLst>
+      <p:ext uri="{BB962C8B-B14F-4D97-AF65-F5344CB8AC3E}">
+        <p14:creationId xmlns:p14="http://schemas.microsoft.com/office/powerpoint/2010/main" val="830814953"/>
+      </p:ext>
+    </p:extLst>
+  </p:cSld>
+  <p:clrMapOvr>
+    <a:masterClrMapping/>
+  </p:clrMapOvr>
+</p:sld>
+</file>
+
+<file path=ppt/slides/slide2.xml><?xml version="1.0" encoding="utf-8"?>
+<p:sld xmlns:a="http://schemas.openxmlformats.org/drawingml/2006/main" xmlns:r="http://schemas.openxmlformats.org/officeDocument/2006/relationships" xmlns:p="http://schemas.openxmlformats.org/presentationml/2006/main">
+  <p:cSld>
+    <p:spTree>
+      <p:nvGrpSpPr>
+        <p:cNvPr id="1" name="">
+          <a:extLst>
+            <a:ext uri="{FF2B5EF4-FFF2-40B4-BE49-F238E27FC236}">
+              <a16:creationId xmlns:a16="http://schemas.microsoft.com/office/drawing/2014/main" id="{45849598-BD4D-70E9-70C2-7215FDC0508E}"/>
+            </a:ext>
+          </a:extLst>
+        </p:cNvPr>
+        <p:cNvGrpSpPr/>
+        <p:nvPr/>
+      </p:nvGrpSpPr>
+      <p:grpSpPr>
+        <a:xfrm>
+          <a:off x="0" y="0"/>
+          <a:ext cx="0" cy="0"/>
+          <a:chOff x="0" y="0"/>
+          <a:chExt cx="0" cy="0"/>
+        </a:xfrm>
+      </p:grpSpPr>
+      <p:sp>
+        <p:nvSpPr>
+          <p:cNvPr id="2" name="Title 1">
+            <a:extLst>
+              <a:ext uri="{FF2B5EF4-FFF2-40B4-BE49-F238E27FC236}">
+                <a16:creationId xmlns:a16="http://schemas.microsoft.com/office/drawing/2014/main" id="{FFF1D083-096E-849D-8015-B191ED5D6A34}"/>
+              </a:ext>
+            </a:extLst>
+          </p:cNvPr>
+          <p:cNvSpPr>
+            <a:spLocks noGrp="1"/>
+          </p:cNvSpPr>
+          <p:nvPr>
+            <p:ph type="title"/>
+          </p:nvPr>
+        </p:nvSpPr>
+        <p:spPr/>
+        <p:txBody>
+          <a:bodyPr>
+            <a:normAutofit/>
+          </a:bodyPr>
+          <a:lstStyle/>
+          <a:p>
+            <a:r>
+              <a:rPr lang="en-US" sz="4000" dirty="0">
+                <a:latin typeface="Helvetica" pitchFamily="2" charset="0"/>
+              </a:rPr>
+              <a:t>Leave us your feedback!</a:t>
+            </a:r>
+          </a:p>
+        </p:txBody>
+      </p:sp>
+      <p:pic>
+        <p:nvPicPr>
+          <p:cNvPr id="2050" name="Picture 2" descr="Suggestion - Free communications icons">
+            <a:extLst>
+              <a:ext uri="{FF2B5EF4-FFF2-40B4-BE49-F238E27FC236}">
+                <a16:creationId xmlns:a16="http://schemas.microsoft.com/office/drawing/2014/main" id="{5020596A-D3B5-18D2-1D37-3B88E5CD788C}"/>
+              </a:ext>
+            </a:extLst>
+          </p:cNvPr>
+          <p:cNvPicPr>
+            <a:picLocks noChangeAspect="1" noChangeArrowheads="1"/>
+          </p:cNvPicPr>
+          <p:nvPr/>
+        </p:nvPicPr>
+        <p:blipFill>
+          <a:blip r:embed="rId2">
+            <a:extLst>
+              <a:ext uri="{28A0092B-C50C-407E-A947-70E740481C1C}">
+                <a14:useLocalDpi xmlns:a14="http://schemas.microsoft.com/office/drawing/2010/main" val="0"/>
+              </a:ext>
+            </a:extLst>
+          </a:blip>
+          <a:srcRect/>
+          <a:stretch>
+            <a:fillRect/>
+          </a:stretch>
+        </p:blipFill>
+        <p:spPr bwMode="auto">
+          <a:xfrm>
+            <a:off x="1182760" y="1866375"/>
+            <a:ext cx="611909" cy="611909"/>
+          </a:xfrm>
+          <a:prstGeom prst="rect">
+            <a:avLst/>
+          </a:prstGeom>
+          <a:noFill/>
+          <a:extLst>
+            <a:ext uri="{909E8E84-426E-40DD-AFC4-6F175D3DCCD1}">
+              <a14:hiddenFill xmlns:a14="http://schemas.microsoft.com/office/drawing/2010/main">
+                <a:solidFill>
+                  <a:srgbClr val="FFFFFF"/>
+                </a:solidFill>
+              </a14:hiddenFill>
+            </a:ext>
+          </a:extLst>
+        </p:spPr>
+      </p:pic>
+      <p:sp>
+        <p:nvSpPr>
+          <p:cNvPr id="3" name="TextBox 2">
+            <a:extLst>
+              <a:ext uri="{FF2B5EF4-FFF2-40B4-BE49-F238E27FC236}">
+                <a16:creationId xmlns:a16="http://schemas.microsoft.com/office/drawing/2014/main" id="{49C98279-5765-9BFA-2B15-04A8FEDAA130}"/>
+              </a:ext>
+            </a:extLst>
+          </p:cNvPr>
+          <p:cNvSpPr txBox="1"/>
+          <p:nvPr/>
+        </p:nvSpPr>
+        <p:spPr>
+          <a:xfrm>
+            <a:off x="1794669" y="2206232"/>
+            <a:ext cx="4606131" cy="2031325"/>
+          </a:xfrm>
+          <a:prstGeom prst="rect">
+            <a:avLst/>
+          </a:prstGeom>
+          <a:noFill/>
+        </p:spPr>
+        <p:txBody>
+          <a:bodyPr wrap="square" rtlCol="0">
+            <a:spAutoFit/>
+          </a:bodyPr>
+          <a:lstStyle/>
+          <a:p>
+            <a:r>
+              <a:rPr lang="en-US" dirty="0">
+                <a:latin typeface="Helvetica" pitchFamily="2" charset="0"/>
+              </a:rPr>
+              <a:t>Please let us know if you have suggestions!</a:t>
+            </a:r>
+          </a:p>
+          <a:p>
+            <a:endParaRPr lang="en-US" dirty="0">
+              <a:latin typeface="Helvetica" pitchFamily="2" charset="0"/>
+            </a:endParaRPr>
+          </a:p>
+          <a:p>
+            <a:pPr marL="342900" indent="-342900">
+              <a:buAutoNum type="arabicPeriod"/>
+            </a:pPr>
+            <a:r>
+              <a:rPr lang="en-US" dirty="0">
+                <a:latin typeface="Helvetica" pitchFamily="2" charset="0"/>
+              </a:rPr>
+              <a:t>What did you like about this workshop?</a:t>
+            </a:r>
+          </a:p>
+          <a:p>
+            <a:pPr marL="342900" indent="-342900">
+              <a:buAutoNum type="arabicPeriod"/>
+            </a:pPr>
+            <a:r>
+              <a:rPr lang="en-US" dirty="0">
+                <a:latin typeface="Helvetica" pitchFamily="2" charset="0"/>
+              </a:rPr>
+              <a:t>What could be improved?</a:t>
+            </a:r>
+          </a:p>
+          <a:p>
+            <a:pPr marL="342900" indent="-342900">
+              <a:buAutoNum type="arabicPeriod"/>
+            </a:pPr>
+            <a:r>
+              <a:rPr lang="en-US" dirty="0">
+                <a:latin typeface="Helvetica" pitchFamily="2" charset="0"/>
+              </a:rPr>
+              <a:t>Any suggestions for the following sessions (i.e. change in order, other topics, special interests)</a:t>
+            </a:r>
+          </a:p>
+        </p:txBody>
+      </p:sp>
+      <p:pic>
+        <p:nvPicPr>
+          <p:cNvPr id="5122" name="Picture 2" descr="Pen Icon Graphic by rudezstudio · Creative Fabrica">
+            <a:extLst>
+              <a:ext uri="{FF2B5EF4-FFF2-40B4-BE49-F238E27FC236}">
+                <a16:creationId xmlns:a16="http://schemas.microsoft.com/office/drawing/2014/main" id="{0DEEB3E2-D200-94F1-EB2C-1F94DD52C3EE}"/>
+              </a:ext>
+            </a:extLst>
+          </p:cNvPr>
+          <p:cNvPicPr>
+            <a:picLocks noChangeAspect="1" noChangeArrowheads="1"/>
+          </p:cNvPicPr>
+          <p:nvPr/>
+        </p:nvPicPr>
+        <p:blipFill>
+          <a:blip r:embed="rId3">
+            <a:extLst>
+              <a:ext uri="{28A0092B-C50C-407E-A947-70E740481C1C}">
+                <a14:useLocalDpi xmlns:a14="http://schemas.microsoft.com/office/drawing/2010/main" val="0"/>
+              </a:ext>
+            </a:extLst>
+          </a:blip>
+          <a:srcRect/>
+          <a:stretch>
+            <a:fillRect/>
+          </a:stretch>
+        </p:blipFill>
+        <p:spPr bwMode="auto">
+          <a:xfrm>
+            <a:off x="6521365" y="340845"/>
+            <a:ext cx="1576712" cy="1049329"/>
+          </a:xfrm>
+          <a:prstGeom prst="rect">
+            <a:avLst/>
+          </a:prstGeom>
+          <a:noFill/>
+          <a:extLst>
+            <a:ext uri="{909E8E84-426E-40DD-AFC4-6F175D3DCCD1}">
+              <a14:hiddenFill xmlns:a14="http://schemas.microsoft.com/office/drawing/2010/main">
+                <a:solidFill>
+                  <a:srgbClr val="FFFFFF"/>
+                </a:solidFill>
+              </a14:hiddenFill>
+            </a:ext>
+          </a:extLst>
+        </p:spPr>
+      </p:pic>
+      <p:pic>
+        <p:nvPicPr>
+          <p:cNvPr id="4" name="Picture 3">
+            <a:extLst>
+              <a:ext uri="{FF2B5EF4-FFF2-40B4-BE49-F238E27FC236}">
+                <a16:creationId xmlns:a16="http://schemas.microsoft.com/office/drawing/2014/main" id="{7EAC7020-766F-B0AF-849C-A72B60F880DB}"/>
+              </a:ext>
+            </a:extLst>
+          </p:cNvPr>
+          <p:cNvPicPr>
+            <a:picLocks noChangeAspect="1"/>
+          </p:cNvPicPr>
+          <p:nvPr/>
+        </p:nvPicPr>
+        <p:blipFill>
+          <a:blip r:embed="rId4"/>
+          <a:stretch>
+            <a:fillRect/>
+          </a:stretch>
+        </p:blipFill>
+        <p:spPr>
+          <a:xfrm>
+            <a:off x="7012709" y="1714968"/>
+            <a:ext cx="4606131" cy="4577873"/>
+          </a:xfrm>
+          <a:prstGeom prst="rect">
+            <a:avLst/>
+          </a:prstGeom>
         </p:spPr>
       </p:pic>
     </p:spTree>

</xml_diff>